<commit_message>
Avances de las correcciones en la metodologia, pendiente justificar rangos
</commit_message>
<xml_diff>
--- a/RESULTADOS MAYO/DIAPOSITIVAS SEMINARIO 9/PROPUESTA WORKFLOW.pptx
+++ b/RESULTADOS MAYO/DIAPOSITIVAS SEMINARIO 9/PROPUESTA WORKFLOW.pptx
@@ -200,7 +200,7 @@
           <a:p>
             <a:fld id="{A6C69894-0122-4BA4-91EF-81B470DE8C70}" type="datetimeFigureOut">
               <a:rPr lang="es-MX" smtClean="0"/>
-              <a:t>26/06/2026</a:t>
+              <a:t>13/09/2026</a:t>
             </a:fld>
             <a:endParaRPr lang="es-MX"/>
           </a:p>
@@ -701,7 +701,7 @@
           <a:p>
             <a:fld id="{A1ECFAA8-8C58-4E04-8B2C-A58AF6FB89F4}" type="datetimeFigureOut">
               <a:rPr lang="es-MX" smtClean="0"/>
-              <a:t>26/06/2026</a:t>
+              <a:t>13/09/2026</a:t>
             </a:fld>
             <a:endParaRPr lang="es-MX"/>
           </a:p>
@@ -901,7 +901,7 @@
           <a:p>
             <a:fld id="{A1ECFAA8-8C58-4E04-8B2C-A58AF6FB89F4}" type="datetimeFigureOut">
               <a:rPr lang="es-MX" smtClean="0"/>
-              <a:t>26/06/2026</a:t>
+              <a:t>13/09/2026</a:t>
             </a:fld>
             <a:endParaRPr lang="es-MX"/>
           </a:p>
@@ -1111,7 +1111,7 @@
           <a:p>
             <a:fld id="{A1ECFAA8-8C58-4E04-8B2C-A58AF6FB89F4}" type="datetimeFigureOut">
               <a:rPr lang="es-MX" smtClean="0"/>
-              <a:t>26/06/2026</a:t>
+              <a:t>13/09/2026</a:t>
             </a:fld>
             <a:endParaRPr lang="es-MX"/>
           </a:p>
@@ -1311,7 +1311,7 @@
           <a:p>
             <a:fld id="{A1ECFAA8-8C58-4E04-8B2C-A58AF6FB89F4}" type="datetimeFigureOut">
               <a:rPr lang="es-MX" smtClean="0"/>
-              <a:t>26/06/2026</a:t>
+              <a:t>13/09/2026</a:t>
             </a:fld>
             <a:endParaRPr lang="es-MX"/>
           </a:p>
@@ -1587,7 +1587,7 @@
           <a:p>
             <a:fld id="{A1ECFAA8-8C58-4E04-8B2C-A58AF6FB89F4}" type="datetimeFigureOut">
               <a:rPr lang="es-MX" smtClean="0"/>
-              <a:t>26/06/2026</a:t>
+              <a:t>13/09/2026</a:t>
             </a:fld>
             <a:endParaRPr lang="es-MX"/>
           </a:p>
@@ -1855,7 +1855,7 @@
           <a:p>
             <a:fld id="{A1ECFAA8-8C58-4E04-8B2C-A58AF6FB89F4}" type="datetimeFigureOut">
               <a:rPr lang="es-MX" smtClean="0"/>
-              <a:t>26/06/2026</a:t>
+              <a:t>13/09/2026</a:t>
             </a:fld>
             <a:endParaRPr lang="es-MX"/>
           </a:p>
@@ -2270,7 +2270,7 @@
           <a:p>
             <a:fld id="{A1ECFAA8-8C58-4E04-8B2C-A58AF6FB89F4}" type="datetimeFigureOut">
               <a:rPr lang="es-MX" smtClean="0"/>
-              <a:t>26/06/2026</a:t>
+              <a:t>13/09/2026</a:t>
             </a:fld>
             <a:endParaRPr lang="es-MX"/>
           </a:p>
@@ -2412,7 +2412,7 @@
           <a:p>
             <a:fld id="{A1ECFAA8-8C58-4E04-8B2C-A58AF6FB89F4}" type="datetimeFigureOut">
               <a:rPr lang="es-MX" smtClean="0"/>
-              <a:t>26/06/2026</a:t>
+              <a:t>13/09/2026</a:t>
             </a:fld>
             <a:endParaRPr lang="es-MX"/>
           </a:p>
@@ -2525,7 +2525,7 @@
           <a:p>
             <a:fld id="{A1ECFAA8-8C58-4E04-8B2C-A58AF6FB89F4}" type="datetimeFigureOut">
               <a:rPr lang="es-MX" smtClean="0"/>
-              <a:t>26/06/2026</a:t>
+              <a:t>13/09/2026</a:t>
             </a:fld>
             <a:endParaRPr lang="es-MX"/>
           </a:p>
@@ -2838,7 +2838,7 @@
           <a:p>
             <a:fld id="{A1ECFAA8-8C58-4E04-8B2C-A58AF6FB89F4}" type="datetimeFigureOut">
               <a:rPr lang="es-MX" smtClean="0"/>
-              <a:t>26/06/2026</a:t>
+              <a:t>13/09/2026</a:t>
             </a:fld>
             <a:endParaRPr lang="es-MX"/>
           </a:p>
@@ -3127,7 +3127,7 @@
           <a:p>
             <a:fld id="{A1ECFAA8-8C58-4E04-8B2C-A58AF6FB89F4}" type="datetimeFigureOut">
               <a:rPr lang="es-MX" smtClean="0"/>
-              <a:t>26/06/2026</a:t>
+              <a:t>13/09/2026</a:t>
             </a:fld>
             <a:endParaRPr lang="es-MX"/>
           </a:p>
@@ -3370,7 +3370,7 @@
           <a:p>
             <a:fld id="{A1ECFAA8-8C58-4E04-8B2C-A58AF6FB89F4}" type="datetimeFigureOut">
               <a:rPr lang="es-MX" smtClean="0"/>
-              <a:t>26/06/2026</a:t>
+              <a:t>13/09/2026</a:t>
             </a:fld>
             <a:endParaRPr lang="es-MX"/>
           </a:p>
@@ -35118,7 +35118,7 @@
           <p:nvPr>
             <p:extLst>
               <p:ext uri="{D42A27DB-BD31-4B8C-83A1-F6EECF244321}">
-                <p14:modId xmlns:p14="http://schemas.microsoft.com/office/powerpoint/2010/main" val="2090204948"/>
+                <p14:modId xmlns:p14="http://schemas.microsoft.com/office/powerpoint/2010/main" val="4249523183"/>
               </p:ext>
             </p:extLst>
           </p:nvPr>
@@ -35504,7 +35504,7 @@
           <p:nvPr>
             <p:extLst>
               <p:ext uri="{D42A27DB-BD31-4B8C-83A1-F6EECF244321}">
-                <p14:modId xmlns:p14="http://schemas.microsoft.com/office/powerpoint/2010/main" val="2207392708"/>
+                <p14:modId xmlns:p14="http://schemas.microsoft.com/office/powerpoint/2010/main" val="1708386842"/>
               </p:ext>
             </p:extLst>
           </p:nvPr>
@@ -35890,7 +35890,7 @@
           <p:nvPr>
             <p:extLst>
               <p:ext uri="{D42A27DB-BD31-4B8C-83A1-F6EECF244321}">
-                <p14:modId xmlns:p14="http://schemas.microsoft.com/office/powerpoint/2010/main" val="602459224"/>
+                <p14:modId xmlns:p14="http://schemas.microsoft.com/office/powerpoint/2010/main" val="1503743819"/>
               </p:ext>
             </p:extLst>
           </p:nvPr>
@@ -36405,7 +36405,7 @@
           <p:nvPr>
             <p:extLst>
               <p:ext uri="{D42A27DB-BD31-4B8C-83A1-F6EECF244321}">
-                <p14:modId xmlns:p14="http://schemas.microsoft.com/office/powerpoint/2010/main" val="594123888"/>
+                <p14:modId xmlns:p14="http://schemas.microsoft.com/office/powerpoint/2010/main" val="389617562"/>
               </p:ext>
             </p:extLst>
           </p:nvPr>
@@ -36791,7 +36791,7 @@
           <p:nvPr>
             <p:extLst>
               <p:ext uri="{D42A27DB-BD31-4B8C-83A1-F6EECF244321}">
-                <p14:modId xmlns:p14="http://schemas.microsoft.com/office/powerpoint/2010/main" val="1389144600"/>
+                <p14:modId xmlns:p14="http://schemas.microsoft.com/office/powerpoint/2010/main" val="1609395293"/>
               </p:ext>
             </p:extLst>
           </p:nvPr>
@@ -37177,7 +37177,7 @@
           <p:nvPr>
             <p:extLst>
               <p:ext uri="{D42A27DB-BD31-4B8C-83A1-F6EECF244321}">
-                <p14:modId xmlns:p14="http://schemas.microsoft.com/office/powerpoint/2010/main" val="4142727697"/>
+                <p14:modId xmlns:p14="http://schemas.microsoft.com/office/powerpoint/2010/main" val="3281015711"/>
               </p:ext>
             </p:extLst>
           </p:nvPr>
@@ -37701,7 +37701,7 @@
           <p:nvPr>
             <p:extLst>
               <p:ext uri="{D42A27DB-BD31-4B8C-83A1-F6EECF244321}">
-                <p14:modId xmlns:p14="http://schemas.microsoft.com/office/powerpoint/2010/main" val="59217389"/>
+                <p14:modId xmlns:p14="http://schemas.microsoft.com/office/powerpoint/2010/main" val="637787821"/>
               </p:ext>
             </p:extLst>
           </p:nvPr>
@@ -38087,7 +38087,7 @@
           <p:nvPr>
             <p:extLst>
               <p:ext uri="{D42A27DB-BD31-4B8C-83A1-F6EECF244321}">
-                <p14:modId xmlns:p14="http://schemas.microsoft.com/office/powerpoint/2010/main" val="3941001807"/>
+                <p14:modId xmlns:p14="http://schemas.microsoft.com/office/powerpoint/2010/main" val="1523653003"/>
               </p:ext>
             </p:extLst>
           </p:nvPr>
@@ -38473,7 +38473,7 @@
           <p:nvPr>
             <p:extLst>
               <p:ext uri="{D42A27DB-BD31-4B8C-83A1-F6EECF244321}">
-                <p14:modId xmlns:p14="http://schemas.microsoft.com/office/powerpoint/2010/main" val="95131865"/>
+                <p14:modId xmlns:p14="http://schemas.microsoft.com/office/powerpoint/2010/main" val="1621221761"/>
               </p:ext>
             </p:extLst>
           </p:nvPr>
@@ -39097,7 +39097,7 @@
           <p:nvPr>
             <p:extLst>
               <p:ext uri="{D42A27DB-BD31-4B8C-83A1-F6EECF244321}">
-                <p14:modId xmlns:p14="http://schemas.microsoft.com/office/powerpoint/2010/main" val="1362265276"/>
+                <p14:modId xmlns:p14="http://schemas.microsoft.com/office/powerpoint/2010/main" val="206397730"/>
               </p:ext>
             </p:extLst>
           </p:nvPr>
@@ -39849,7 +39849,13 @@
           <p:cNvGraphicFramePr>
             <a:graphicFrameLocks noGrp="1"/>
           </p:cNvGraphicFramePr>
-          <p:nvPr/>
+          <p:nvPr>
+            <p:extLst>
+              <p:ext uri="{D42A27DB-BD31-4B8C-83A1-F6EECF244321}">
+                <p14:modId xmlns:p14="http://schemas.microsoft.com/office/powerpoint/2010/main" val="1305795232"/>
+              </p:ext>
+            </p:extLst>
+          </p:nvPr>
         </p:nvGraphicFramePr>
         <p:xfrm>
           <a:off x="8345597" y="1126252"/>
@@ -40298,7 +40304,13 @@
           <p:cNvGraphicFramePr>
             <a:graphicFrameLocks noGrp="1"/>
           </p:cNvGraphicFramePr>
-          <p:nvPr/>
+          <p:nvPr>
+            <p:extLst>
+              <p:ext uri="{D42A27DB-BD31-4B8C-83A1-F6EECF244321}">
+                <p14:modId xmlns:p14="http://schemas.microsoft.com/office/powerpoint/2010/main" val="3595772508"/>
+              </p:ext>
+            </p:extLst>
+          </p:nvPr>
         </p:nvGraphicFramePr>
         <p:xfrm>
           <a:off x="8348361" y="1393242"/>
@@ -40747,7 +40759,13 @@
           <p:cNvGraphicFramePr>
             <a:graphicFrameLocks noGrp="1"/>
           </p:cNvGraphicFramePr>
-          <p:nvPr/>
+          <p:nvPr>
+            <p:extLst>
+              <p:ext uri="{D42A27DB-BD31-4B8C-83A1-F6EECF244321}">
+                <p14:modId xmlns:p14="http://schemas.microsoft.com/office/powerpoint/2010/main" val="1507442430"/>
+              </p:ext>
+            </p:extLst>
+          </p:nvPr>
         </p:nvGraphicFramePr>
         <p:xfrm>
           <a:off x="8345597" y="1660232"/>
@@ -41308,7 +41326,13 @@
           <p:cNvGraphicFramePr>
             <a:graphicFrameLocks noGrp="1"/>
           </p:cNvGraphicFramePr>
-          <p:nvPr/>
+          <p:nvPr>
+            <p:extLst>
+              <p:ext uri="{D42A27DB-BD31-4B8C-83A1-F6EECF244321}">
+                <p14:modId xmlns:p14="http://schemas.microsoft.com/office/powerpoint/2010/main" val="1386396559"/>
+              </p:ext>
+            </p:extLst>
+          </p:nvPr>
         </p:nvGraphicFramePr>
         <p:xfrm>
           <a:off x="8444393" y="2739081"/>
@@ -41757,7 +41781,13 @@
           <p:cNvGraphicFramePr>
             <a:graphicFrameLocks noGrp="1"/>
           </p:cNvGraphicFramePr>
-          <p:nvPr/>
+          <p:nvPr>
+            <p:extLst>
+              <p:ext uri="{D42A27DB-BD31-4B8C-83A1-F6EECF244321}">
+                <p14:modId xmlns:p14="http://schemas.microsoft.com/office/powerpoint/2010/main" val="1394724850"/>
+              </p:ext>
+            </p:extLst>
+          </p:nvPr>
         </p:nvGraphicFramePr>
         <p:xfrm>
           <a:off x="8461117" y="3006071"/>
@@ -42206,7 +42236,13 @@
           <p:cNvGraphicFramePr>
             <a:graphicFrameLocks noGrp="1"/>
           </p:cNvGraphicFramePr>
-          <p:nvPr/>
+          <p:nvPr>
+            <p:extLst>
+              <p:ext uri="{D42A27DB-BD31-4B8C-83A1-F6EECF244321}">
+                <p14:modId xmlns:p14="http://schemas.microsoft.com/office/powerpoint/2010/main" val="1601898243"/>
+              </p:ext>
+            </p:extLst>
+          </p:nvPr>
         </p:nvGraphicFramePr>
         <p:xfrm>
           <a:off x="8479294" y="3273061"/>
@@ -42787,7 +42823,13 @@
           <p:cNvGraphicFramePr>
             <a:graphicFrameLocks noGrp="1"/>
           </p:cNvGraphicFramePr>
-          <p:nvPr/>
+          <p:nvPr>
+            <p:extLst>
+              <p:ext uri="{D42A27DB-BD31-4B8C-83A1-F6EECF244321}">
+                <p14:modId xmlns:p14="http://schemas.microsoft.com/office/powerpoint/2010/main" val="1648607873"/>
+              </p:ext>
+            </p:extLst>
+          </p:nvPr>
         </p:nvGraphicFramePr>
         <p:xfrm>
           <a:off x="8251707" y="4472013"/>
@@ -43236,7 +43278,13 @@
           <p:cNvGraphicFramePr>
             <a:graphicFrameLocks noGrp="1"/>
           </p:cNvGraphicFramePr>
-          <p:nvPr/>
+          <p:nvPr>
+            <p:extLst>
+              <p:ext uri="{D42A27DB-BD31-4B8C-83A1-F6EECF244321}">
+                <p14:modId xmlns:p14="http://schemas.microsoft.com/office/powerpoint/2010/main" val="3217894772"/>
+              </p:ext>
+            </p:extLst>
+          </p:nvPr>
         </p:nvGraphicFramePr>
         <p:xfrm>
           <a:off x="8242979" y="4763830"/>
@@ -43685,7 +43733,13 @@
           <p:cNvGraphicFramePr>
             <a:graphicFrameLocks noGrp="1"/>
           </p:cNvGraphicFramePr>
-          <p:nvPr/>
+          <p:nvPr>
+            <p:extLst>
+              <p:ext uri="{D42A27DB-BD31-4B8C-83A1-F6EECF244321}">
+                <p14:modId xmlns:p14="http://schemas.microsoft.com/office/powerpoint/2010/main" val="3077478672"/>
+              </p:ext>
+            </p:extLst>
+          </p:nvPr>
         </p:nvGraphicFramePr>
         <p:xfrm>
           <a:off x="8249959" y="5055647"/>
@@ -44284,7 +44338,7 @@
           <p:nvPr>
             <p:extLst>
               <p:ext uri="{D42A27DB-BD31-4B8C-83A1-F6EECF244321}">
-                <p14:modId xmlns:p14="http://schemas.microsoft.com/office/powerpoint/2010/main" val="52371720"/>
+                <p14:modId xmlns:p14="http://schemas.microsoft.com/office/powerpoint/2010/main" val="4056790598"/>
               </p:ext>
             </p:extLst>
           </p:nvPr>

</xml_diff>